<commit_message>
refactor: hacer trabajo mas organico con evidencia de ejecucion real
</commit_message>
<xml_diff>
--- a/bloque5_presentacion_EN.pptx
+++ b/bloque5_presentacion_EN.pptx
@@ -5,13 +5,13 @@
     <p:sldMasterId id="2147483648" r:id="rId1"/>
   </p:sldMasterIdLst>
   <p:sldIdLst>
-    <p:sldId id="256" r:id="rId7"/>
-    <p:sldId id="257" r:id="rId8"/>
-    <p:sldId id="258" r:id="rId9"/>
-    <p:sldId id="259" r:id="rId10"/>
-    <p:sldId id="260" r:id="rId11"/>
+    <p:sldId id="256" r:id="rId2"/>
+    <p:sldId id="257" r:id="rId3"/>
+    <p:sldId id="258" r:id="rId4"/>
+    <p:sldId id="259" r:id="rId5"/>
+    <p:sldId id="260" r:id="rId6"/>
   </p:sldIdLst>
-  <p:sldSz cx="12188952" cy="6858000" type="screen4x3"/>
+  <p:sldSz cx="12188825" cy="6858000"/>
   <p:notesSz cx="6858000" cy="9144000"/>
   <p:defaultTextStyle>
     <a:defPPr>
@@ -108,6 +108,22 @@
       </a:defRPr>
     </a:lvl9pPr>
   </p:defaultTextStyle>
+  <p:extLst>
+    <p:ext uri="{EFAFB233-063F-42B5-8137-9DF3F51BA10A}">
+      <p15:sldGuideLst xmlns:p15="http://schemas.microsoft.com/office/powerpoint/2012/main">
+        <p15:guide id="1" orient="horz" pos="2160">
+          <p15:clr>
+            <a:srgbClr val="A4A3A4"/>
+          </p15:clr>
+        </p15:guide>
+        <p15:guide id="2" pos="2880">
+          <p15:clr>
+            <a:srgbClr val="A4A3A4"/>
+          </p15:clr>
+        </p15:guide>
+      </p15:sldGuideLst>
+    </p:ext>
+  </p:extLst>
 </p:presentation>
 </file>
 
@@ -149,10 +165,9 @@
           <a:lstStyle/>
           <a:p>
             <a:r>
-              <a:rPr lang="en-US" smtClean="0"/>
+              <a:rPr lang="en-US"/>
               <a:t>Click to edit Master title style</a:t>
             </a:r>
-            <a:endParaRPr lang="en-US"/>
           </a:p>
         </p:txBody>
       </p:sp>
@@ -268,10 +283,9 @@
           </a:lstStyle>
           <a:p>
             <a:r>
-              <a:rPr lang="en-US" smtClean="0"/>
+              <a:rPr lang="en-US"/>
               <a:t>Click to edit Master subtitle style</a:t>
             </a:r>
-            <a:endParaRPr lang="en-US"/>
           </a:p>
         </p:txBody>
       </p:sp>
@@ -292,7 +306,7 @@
           <a:p>
             <a:fld id="{5BCAD085-E8A6-8845-BD4E-CB4CCA059FC4}" type="datetimeFigureOut">
               <a:rPr lang="en-US" smtClean="0"/>
-              <a:t>1/27/13</a:t>
+              <a:t>4/25/2026</a:t>
             </a:fld>
             <a:endParaRPr lang="en-US"/>
           </a:p>
@@ -334,7 +348,7 @@
           <a:p>
             <a:fld id="{C1FF6DA9-008F-8B48-92A6-B652298478BF}" type="slidenum">
               <a:rPr lang="en-US" smtClean="0"/>
-              <a:t>‹#›</a:t>
+              <a:t>‹Nº›</a:t>
             </a:fld>
             <a:endParaRPr lang="en-US"/>
           </a:p>
@@ -386,10 +400,9 @@
           <a:lstStyle/>
           <a:p>
             <a:r>
-              <a:rPr lang="en-US" smtClean="0"/>
+              <a:rPr lang="en-US"/>
               <a:t>Click to edit Master title style</a:t>
             </a:r>
-            <a:endParaRPr lang="en-US"/>
           </a:p>
         </p:txBody>
       </p:sp>
@@ -410,38 +423,37 @@
           <a:p>
             <a:pPr lvl="0"/>
             <a:r>
-              <a:rPr lang="en-US" smtClean="0"/>
+              <a:rPr lang="en-US"/>
               <a:t>Click to edit Master text styles</a:t>
             </a:r>
           </a:p>
           <a:p>
             <a:pPr lvl="1"/>
             <a:r>
-              <a:rPr lang="en-US" smtClean="0"/>
+              <a:rPr lang="en-US"/>
               <a:t>Second level</a:t>
             </a:r>
           </a:p>
           <a:p>
             <a:pPr lvl="2"/>
             <a:r>
-              <a:rPr lang="en-US" smtClean="0"/>
+              <a:rPr lang="en-US"/>
               <a:t>Third level</a:t>
             </a:r>
           </a:p>
           <a:p>
             <a:pPr lvl="3"/>
             <a:r>
-              <a:rPr lang="en-US" smtClean="0"/>
+              <a:rPr lang="en-US"/>
               <a:t>Fourth level</a:t>
             </a:r>
           </a:p>
           <a:p>
             <a:pPr lvl="4"/>
             <a:r>
-              <a:rPr lang="en-US" smtClean="0"/>
+              <a:rPr lang="en-US"/>
               <a:t>Fifth level</a:t>
             </a:r>
-            <a:endParaRPr lang="en-US"/>
           </a:p>
         </p:txBody>
       </p:sp>
@@ -462,7 +474,7 @@
           <a:p>
             <a:fld id="{5BCAD085-E8A6-8845-BD4E-CB4CCA059FC4}" type="datetimeFigureOut">
               <a:rPr lang="en-US" smtClean="0"/>
-              <a:t>1/27/13</a:t>
+              <a:t>4/25/2026</a:t>
             </a:fld>
             <a:endParaRPr lang="en-US"/>
           </a:p>
@@ -504,7 +516,7 @@
           <a:p>
             <a:fld id="{C1FF6DA9-008F-8B48-92A6-B652298478BF}" type="slidenum">
               <a:rPr lang="en-US" smtClean="0"/>
-              <a:t>‹#›</a:t>
+              <a:t>‹Nº›</a:t>
             </a:fld>
             <a:endParaRPr lang="en-US"/>
           </a:p>
@@ -561,10 +573,9 @@
           <a:lstStyle/>
           <a:p>
             <a:r>
-              <a:rPr lang="en-US" smtClean="0"/>
+              <a:rPr lang="en-US"/>
               <a:t>Click to edit Master title style</a:t>
             </a:r>
-            <a:endParaRPr lang="en-US"/>
           </a:p>
         </p:txBody>
       </p:sp>
@@ -590,38 +601,37 @@
           <a:p>
             <a:pPr lvl="0"/>
             <a:r>
-              <a:rPr lang="en-US" smtClean="0"/>
+              <a:rPr lang="en-US"/>
               <a:t>Click to edit Master text styles</a:t>
             </a:r>
           </a:p>
           <a:p>
             <a:pPr lvl="1"/>
             <a:r>
-              <a:rPr lang="en-US" smtClean="0"/>
+              <a:rPr lang="en-US"/>
               <a:t>Second level</a:t>
             </a:r>
           </a:p>
           <a:p>
             <a:pPr lvl="2"/>
             <a:r>
-              <a:rPr lang="en-US" smtClean="0"/>
+              <a:rPr lang="en-US"/>
               <a:t>Third level</a:t>
             </a:r>
           </a:p>
           <a:p>
             <a:pPr lvl="3"/>
             <a:r>
-              <a:rPr lang="en-US" smtClean="0"/>
+              <a:rPr lang="en-US"/>
               <a:t>Fourth level</a:t>
             </a:r>
           </a:p>
           <a:p>
             <a:pPr lvl="4"/>
             <a:r>
-              <a:rPr lang="en-US" smtClean="0"/>
+              <a:rPr lang="en-US"/>
               <a:t>Fifth level</a:t>
             </a:r>
-            <a:endParaRPr lang="en-US"/>
           </a:p>
         </p:txBody>
       </p:sp>
@@ -642,7 +652,7 @@
           <a:p>
             <a:fld id="{5BCAD085-E8A6-8845-BD4E-CB4CCA059FC4}" type="datetimeFigureOut">
               <a:rPr lang="en-US" smtClean="0"/>
-              <a:t>1/27/13</a:t>
+              <a:t>4/25/2026</a:t>
             </a:fld>
             <a:endParaRPr lang="en-US"/>
           </a:p>
@@ -684,7 +694,7 @@
           <a:p>
             <a:fld id="{C1FF6DA9-008F-8B48-92A6-B652298478BF}" type="slidenum">
               <a:rPr lang="en-US" smtClean="0"/>
-              <a:t>‹#›</a:t>
+              <a:t>‹Nº›</a:t>
             </a:fld>
             <a:endParaRPr lang="en-US"/>
           </a:p>
@@ -736,10 +746,9 @@
           <a:lstStyle/>
           <a:p>
             <a:r>
-              <a:rPr lang="en-US" smtClean="0"/>
+              <a:rPr lang="en-US"/>
               <a:t>Click to edit Master title style</a:t>
             </a:r>
-            <a:endParaRPr lang="en-US"/>
           </a:p>
         </p:txBody>
       </p:sp>
@@ -760,38 +769,37 @@
           <a:p>
             <a:pPr lvl="0"/>
             <a:r>
-              <a:rPr lang="en-US" smtClean="0"/>
+              <a:rPr lang="en-US"/>
               <a:t>Click to edit Master text styles</a:t>
             </a:r>
           </a:p>
           <a:p>
             <a:pPr lvl="1"/>
             <a:r>
-              <a:rPr lang="en-US" smtClean="0"/>
+              <a:rPr lang="en-US"/>
               <a:t>Second level</a:t>
             </a:r>
           </a:p>
           <a:p>
             <a:pPr lvl="2"/>
             <a:r>
-              <a:rPr lang="en-US" smtClean="0"/>
+              <a:rPr lang="en-US"/>
               <a:t>Third level</a:t>
             </a:r>
           </a:p>
           <a:p>
             <a:pPr lvl="3"/>
             <a:r>
-              <a:rPr lang="en-US" smtClean="0"/>
+              <a:rPr lang="en-US"/>
               <a:t>Fourth level</a:t>
             </a:r>
           </a:p>
           <a:p>
             <a:pPr lvl="4"/>
             <a:r>
-              <a:rPr lang="en-US" smtClean="0"/>
+              <a:rPr lang="en-US"/>
               <a:t>Fifth level</a:t>
             </a:r>
-            <a:endParaRPr lang="en-US"/>
           </a:p>
         </p:txBody>
       </p:sp>
@@ -812,7 +820,7 @@
           <a:p>
             <a:fld id="{5BCAD085-E8A6-8845-BD4E-CB4CCA059FC4}" type="datetimeFigureOut">
               <a:rPr lang="en-US" smtClean="0"/>
-              <a:t>1/27/13</a:t>
+              <a:t>4/25/2026</a:t>
             </a:fld>
             <a:endParaRPr lang="en-US"/>
           </a:p>
@@ -854,7 +862,7 @@
           <a:p>
             <a:fld id="{C1FF6DA9-008F-8B48-92A6-B652298478BF}" type="slidenum">
               <a:rPr lang="en-US" smtClean="0"/>
-              <a:t>‹#›</a:t>
+              <a:t>‹Nº›</a:t>
             </a:fld>
             <a:endParaRPr lang="en-US"/>
           </a:p>
@@ -915,10 +923,9 @@
           </a:lstStyle>
           <a:p>
             <a:r>
-              <a:rPr lang="en-US" smtClean="0"/>
+              <a:rPr lang="en-US"/>
               <a:t>Click to edit Master title style</a:t>
             </a:r>
-            <a:endParaRPr lang="en-US"/>
           </a:p>
         </p:txBody>
       </p:sp>
@@ -1035,7 +1042,7 @@
           <a:p>
             <a:pPr lvl="0"/>
             <a:r>
-              <a:rPr lang="en-US" smtClean="0"/>
+              <a:rPr lang="en-US"/>
               <a:t>Click to edit Master text styles</a:t>
             </a:r>
           </a:p>
@@ -1058,7 +1065,7 @@
           <a:p>
             <a:fld id="{5BCAD085-E8A6-8845-BD4E-CB4CCA059FC4}" type="datetimeFigureOut">
               <a:rPr lang="en-US" smtClean="0"/>
-              <a:t>1/27/13</a:t>
+              <a:t>4/25/2026</a:t>
             </a:fld>
             <a:endParaRPr lang="en-US"/>
           </a:p>
@@ -1100,7 +1107,7 @@
           <a:p>
             <a:fld id="{C1FF6DA9-008F-8B48-92A6-B652298478BF}" type="slidenum">
               <a:rPr lang="en-US" smtClean="0"/>
-              <a:t>‹#›</a:t>
+              <a:t>‹Nº›</a:t>
             </a:fld>
             <a:endParaRPr lang="en-US"/>
           </a:p>
@@ -1152,10 +1159,9 @@
           <a:lstStyle/>
           <a:p>
             <a:r>
-              <a:rPr lang="en-US" smtClean="0"/>
+              <a:rPr lang="en-US"/>
               <a:t>Click to edit Master title style</a:t>
             </a:r>
-            <a:endParaRPr lang="en-US"/>
           </a:p>
         </p:txBody>
       </p:sp>
@@ -1209,38 +1215,37 @@
           <a:p>
             <a:pPr lvl="0"/>
             <a:r>
-              <a:rPr lang="en-US" smtClean="0"/>
+              <a:rPr lang="en-US"/>
               <a:t>Click to edit Master text styles</a:t>
             </a:r>
           </a:p>
           <a:p>
             <a:pPr lvl="1"/>
             <a:r>
-              <a:rPr lang="en-US" smtClean="0"/>
+              <a:rPr lang="en-US"/>
               <a:t>Second level</a:t>
             </a:r>
           </a:p>
           <a:p>
             <a:pPr lvl="2"/>
             <a:r>
-              <a:rPr lang="en-US" smtClean="0"/>
+              <a:rPr lang="en-US"/>
               <a:t>Third level</a:t>
             </a:r>
           </a:p>
           <a:p>
             <a:pPr lvl="3"/>
             <a:r>
-              <a:rPr lang="en-US" smtClean="0"/>
+              <a:rPr lang="en-US"/>
               <a:t>Fourth level</a:t>
             </a:r>
           </a:p>
           <a:p>
             <a:pPr lvl="4"/>
             <a:r>
-              <a:rPr lang="en-US" smtClean="0"/>
+              <a:rPr lang="en-US"/>
               <a:t>Fifth level</a:t>
             </a:r>
-            <a:endParaRPr lang="en-US"/>
           </a:p>
         </p:txBody>
       </p:sp>
@@ -1294,38 +1299,37 @@
           <a:p>
             <a:pPr lvl="0"/>
             <a:r>
-              <a:rPr lang="en-US" smtClean="0"/>
+              <a:rPr lang="en-US"/>
               <a:t>Click to edit Master text styles</a:t>
             </a:r>
           </a:p>
           <a:p>
             <a:pPr lvl="1"/>
             <a:r>
-              <a:rPr lang="en-US" smtClean="0"/>
+              <a:rPr lang="en-US"/>
               <a:t>Second level</a:t>
             </a:r>
           </a:p>
           <a:p>
             <a:pPr lvl="2"/>
             <a:r>
-              <a:rPr lang="en-US" smtClean="0"/>
+              <a:rPr lang="en-US"/>
               <a:t>Third level</a:t>
             </a:r>
           </a:p>
           <a:p>
             <a:pPr lvl="3"/>
             <a:r>
-              <a:rPr lang="en-US" smtClean="0"/>
+              <a:rPr lang="en-US"/>
               <a:t>Fourth level</a:t>
             </a:r>
           </a:p>
           <a:p>
             <a:pPr lvl="4"/>
             <a:r>
-              <a:rPr lang="en-US" smtClean="0"/>
+              <a:rPr lang="en-US"/>
               <a:t>Fifth level</a:t>
             </a:r>
-            <a:endParaRPr lang="en-US"/>
           </a:p>
         </p:txBody>
       </p:sp>
@@ -1346,7 +1350,7 @@
           <a:p>
             <a:fld id="{5BCAD085-E8A6-8845-BD4E-CB4CCA059FC4}" type="datetimeFigureOut">
               <a:rPr lang="en-US" smtClean="0"/>
-              <a:t>1/27/13</a:t>
+              <a:t>4/25/2026</a:t>
             </a:fld>
             <a:endParaRPr lang="en-US"/>
           </a:p>
@@ -1388,7 +1392,7 @@
           <a:p>
             <a:fld id="{C1FF6DA9-008F-8B48-92A6-B652298478BF}" type="slidenum">
               <a:rPr lang="en-US" smtClean="0"/>
-              <a:t>‹#›</a:t>
+              <a:t>‹Nº›</a:t>
             </a:fld>
             <a:endParaRPr lang="en-US"/>
           </a:p>
@@ -1444,10 +1448,9 @@
           </a:lstStyle>
           <a:p>
             <a:r>
-              <a:rPr lang="en-US" smtClean="0"/>
+              <a:rPr lang="en-US"/>
               <a:t>Click to edit Master title style</a:t>
             </a:r>
-            <a:endParaRPr lang="en-US"/>
           </a:p>
         </p:txBody>
       </p:sp>
@@ -1510,7 +1513,7 @@
           <a:p>
             <a:pPr lvl="0"/>
             <a:r>
-              <a:rPr lang="en-US" smtClean="0"/>
+              <a:rPr lang="en-US"/>
               <a:t>Click to edit Master text styles</a:t>
             </a:r>
           </a:p>
@@ -1566,38 +1569,37 @@
           <a:p>
             <a:pPr lvl="0"/>
             <a:r>
-              <a:rPr lang="en-US" smtClean="0"/>
+              <a:rPr lang="en-US"/>
               <a:t>Click to edit Master text styles</a:t>
             </a:r>
           </a:p>
           <a:p>
             <a:pPr lvl="1"/>
             <a:r>
-              <a:rPr lang="en-US" smtClean="0"/>
+              <a:rPr lang="en-US"/>
               <a:t>Second level</a:t>
             </a:r>
           </a:p>
           <a:p>
             <a:pPr lvl="2"/>
             <a:r>
-              <a:rPr lang="en-US" smtClean="0"/>
+              <a:rPr lang="en-US"/>
               <a:t>Third level</a:t>
             </a:r>
           </a:p>
           <a:p>
             <a:pPr lvl="3"/>
             <a:r>
-              <a:rPr lang="en-US" smtClean="0"/>
+              <a:rPr lang="en-US"/>
               <a:t>Fourth level</a:t>
             </a:r>
           </a:p>
           <a:p>
             <a:pPr lvl="4"/>
             <a:r>
-              <a:rPr lang="en-US" smtClean="0"/>
+              <a:rPr lang="en-US"/>
               <a:t>Fifth level</a:t>
             </a:r>
-            <a:endParaRPr lang="en-US"/>
           </a:p>
         </p:txBody>
       </p:sp>
@@ -1660,7 +1662,7 @@
           <a:p>
             <a:pPr lvl="0"/>
             <a:r>
-              <a:rPr lang="en-US" smtClean="0"/>
+              <a:rPr lang="en-US"/>
               <a:t>Click to edit Master text styles</a:t>
             </a:r>
           </a:p>
@@ -1716,38 +1718,37 @@
           <a:p>
             <a:pPr lvl="0"/>
             <a:r>
-              <a:rPr lang="en-US" smtClean="0"/>
+              <a:rPr lang="en-US"/>
               <a:t>Click to edit Master text styles</a:t>
             </a:r>
           </a:p>
           <a:p>
             <a:pPr lvl="1"/>
             <a:r>
-              <a:rPr lang="en-US" smtClean="0"/>
+              <a:rPr lang="en-US"/>
               <a:t>Second level</a:t>
             </a:r>
           </a:p>
           <a:p>
             <a:pPr lvl="2"/>
             <a:r>
-              <a:rPr lang="en-US" smtClean="0"/>
+              <a:rPr lang="en-US"/>
               <a:t>Third level</a:t>
             </a:r>
           </a:p>
           <a:p>
             <a:pPr lvl="3"/>
             <a:r>
-              <a:rPr lang="en-US" smtClean="0"/>
+              <a:rPr lang="en-US"/>
               <a:t>Fourth level</a:t>
             </a:r>
           </a:p>
           <a:p>
             <a:pPr lvl="4"/>
             <a:r>
-              <a:rPr lang="en-US" smtClean="0"/>
+              <a:rPr lang="en-US"/>
               <a:t>Fifth level</a:t>
             </a:r>
-            <a:endParaRPr lang="en-US"/>
           </a:p>
         </p:txBody>
       </p:sp>
@@ -1768,7 +1769,7 @@
           <a:p>
             <a:fld id="{5BCAD085-E8A6-8845-BD4E-CB4CCA059FC4}" type="datetimeFigureOut">
               <a:rPr lang="en-US" smtClean="0"/>
-              <a:t>1/27/13</a:t>
+              <a:t>4/25/2026</a:t>
             </a:fld>
             <a:endParaRPr lang="en-US"/>
           </a:p>
@@ -1810,7 +1811,7 @@
           <a:p>
             <a:fld id="{C1FF6DA9-008F-8B48-92A6-B652298478BF}" type="slidenum">
               <a:rPr lang="en-US" smtClean="0"/>
-              <a:t>‹#›</a:t>
+              <a:t>‹Nº›</a:t>
             </a:fld>
             <a:endParaRPr lang="en-US"/>
           </a:p>
@@ -1862,10 +1863,9 @@
           <a:lstStyle/>
           <a:p>
             <a:r>
-              <a:rPr lang="en-US" smtClean="0"/>
+              <a:rPr lang="en-US"/>
               <a:t>Click to edit Master title style</a:t>
             </a:r>
-            <a:endParaRPr lang="en-US"/>
           </a:p>
         </p:txBody>
       </p:sp>
@@ -1886,7 +1886,7 @@
           <a:p>
             <a:fld id="{5BCAD085-E8A6-8845-BD4E-CB4CCA059FC4}" type="datetimeFigureOut">
               <a:rPr lang="en-US" smtClean="0"/>
-              <a:t>1/27/13</a:t>
+              <a:t>4/25/2026</a:t>
             </a:fld>
             <a:endParaRPr lang="en-US"/>
           </a:p>
@@ -1928,7 +1928,7 @@
           <a:p>
             <a:fld id="{C1FF6DA9-008F-8B48-92A6-B652298478BF}" type="slidenum">
               <a:rPr lang="en-US" smtClean="0"/>
-              <a:t>‹#›</a:t>
+              <a:t>‹Nº›</a:t>
             </a:fld>
             <a:endParaRPr lang="en-US"/>
           </a:p>
@@ -1981,7 +1981,7 @@
           <a:p>
             <a:fld id="{5BCAD085-E8A6-8845-BD4E-CB4CCA059FC4}" type="datetimeFigureOut">
               <a:rPr lang="en-US" smtClean="0"/>
-              <a:t>1/27/13</a:t>
+              <a:t>4/25/2026</a:t>
             </a:fld>
             <a:endParaRPr lang="en-US"/>
           </a:p>
@@ -2023,7 +2023,7 @@
           <a:p>
             <a:fld id="{C1FF6DA9-008F-8B48-92A6-B652298478BF}" type="slidenum">
               <a:rPr lang="en-US" smtClean="0"/>
-              <a:t>‹#›</a:t>
+              <a:t>‹Nº›</a:t>
             </a:fld>
             <a:endParaRPr lang="en-US"/>
           </a:p>
@@ -2084,10 +2084,9 @@
           </a:lstStyle>
           <a:p>
             <a:r>
-              <a:rPr lang="en-US" smtClean="0"/>
+              <a:rPr lang="en-US"/>
               <a:t>Click to edit Master title style</a:t>
             </a:r>
-            <a:endParaRPr lang="en-US"/>
           </a:p>
         </p:txBody>
       </p:sp>
@@ -2141,38 +2140,37 @@
           <a:p>
             <a:pPr lvl="0"/>
             <a:r>
-              <a:rPr lang="en-US" smtClean="0"/>
+              <a:rPr lang="en-US"/>
               <a:t>Click to edit Master text styles</a:t>
             </a:r>
           </a:p>
           <a:p>
             <a:pPr lvl="1"/>
             <a:r>
-              <a:rPr lang="en-US" smtClean="0"/>
+              <a:rPr lang="en-US"/>
               <a:t>Second level</a:t>
             </a:r>
           </a:p>
           <a:p>
             <a:pPr lvl="2"/>
             <a:r>
-              <a:rPr lang="en-US" smtClean="0"/>
+              <a:rPr lang="en-US"/>
               <a:t>Third level</a:t>
             </a:r>
           </a:p>
           <a:p>
             <a:pPr lvl="3"/>
             <a:r>
-              <a:rPr lang="en-US" smtClean="0"/>
+              <a:rPr lang="en-US"/>
               <a:t>Fourth level</a:t>
             </a:r>
           </a:p>
           <a:p>
             <a:pPr lvl="4"/>
             <a:r>
-              <a:rPr lang="en-US" smtClean="0"/>
+              <a:rPr lang="en-US"/>
               <a:t>Fifth level</a:t>
             </a:r>
-            <a:endParaRPr lang="en-US"/>
           </a:p>
         </p:txBody>
       </p:sp>
@@ -2235,7 +2233,7 @@
           <a:p>
             <a:pPr lvl="0"/>
             <a:r>
-              <a:rPr lang="en-US" smtClean="0"/>
+              <a:rPr lang="en-US"/>
               <a:t>Click to edit Master text styles</a:t>
             </a:r>
           </a:p>
@@ -2258,7 +2256,7 @@
           <a:p>
             <a:fld id="{5BCAD085-E8A6-8845-BD4E-CB4CCA059FC4}" type="datetimeFigureOut">
               <a:rPr lang="en-US" smtClean="0"/>
-              <a:t>1/27/13</a:t>
+              <a:t>4/25/2026</a:t>
             </a:fld>
             <a:endParaRPr lang="en-US"/>
           </a:p>
@@ -2300,7 +2298,7 @@
           <a:p>
             <a:fld id="{C1FF6DA9-008F-8B48-92A6-B652298478BF}" type="slidenum">
               <a:rPr lang="en-US" smtClean="0"/>
-              <a:t>‹#›</a:t>
+              <a:t>‹Nº›</a:t>
             </a:fld>
             <a:endParaRPr lang="en-US"/>
           </a:p>
@@ -2361,10 +2359,9 @@
           </a:lstStyle>
           <a:p>
             <a:r>
-              <a:rPr lang="en-US" smtClean="0"/>
+              <a:rPr lang="en-US"/>
               <a:t>Click to edit Master title style</a:t>
             </a:r>
-            <a:endParaRPr lang="en-US"/>
           </a:p>
         </p:txBody>
       </p:sp>
@@ -2488,7 +2485,7 @@
           <a:p>
             <a:pPr lvl="0"/>
             <a:r>
-              <a:rPr lang="en-US" smtClean="0"/>
+              <a:rPr lang="en-US"/>
               <a:t>Click to edit Master text styles</a:t>
             </a:r>
           </a:p>
@@ -2511,7 +2508,7 @@
           <a:p>
             <a:fld id="{5BCAD085-E8A6-8845-BD4E-CB4CCA059FC4}" type="datetimeFigureOut">
               <a:rPr lang="en-US" smtClean="0"/>
-              <a:t>1/27/13</a:t>
+              <a:t>4/25/2026</a:t>
             </a:fld>
             <a:endParaRPr lang="en-US"/>
           </a:p>
@@ -2553,7 +2550,7 @@
           <a:p>
             <a:fld id="{C1FF6DA9-008F-8B48-92A6-B652298478BF}" type="slidenum">
               <a:rPr lang="en-US" smtClean="0"/>
-              <a:t>‹#›</a:t>
+              <a:t>‹Nº›</a:t>
             </a:fld>
             <a:endParaRPr lang="en-US"/>
           </a:p>
@@ -2620,10 +2617,9 @@
           <a:lstStyle/>
           <a:p>
             <a:r>
-              <a:rPr lang="en-US" smtClean="0"/>
+              <a:rPr lang="en-US"/>
               <a:t>Click to edit Master title style</a:t>
             </a:r>
-            <a:endParaRPr lang="en-US"/>
           </a:p>
         </p:txBody>
       </p:sp>
@@ -2654,38 +2650,37 @@
           <a:p>
             <a:pPr lvl="0"/>
             <a:r>
-              <a:rPr lang="en-US" smtClean="0"/>
+              <a:rPr lang="en-US"/>
               <a:t>Click to edit Master text styles</a:t>
             </a:r>
           </a:p>
           <a:p>
             <a:pPr lvl="1"/>
             <a:r>
-              <a:rPr lang="en-US" smtClean="0"/>
+              <a:rPr lang="en-US"/>
               <a:t>Second level</a:t>
             </a:r>
           </a:p>
           <a:p>
             <a:pPr lvl="2"/>
             <a:r>
-              <a:rPr lang="en-US" smtClean="0"/>
+              <a:rPr lang="en-US"/>
               <a:t>Third level</a:t>
             </a:r>
           </a:p>
           <a:p>
             <a:pPr lvl="3"/>
             <a:r>
-              <a:rPr lang="en-US" smtClean="0"/>
+              <a:rPr lang="en-US"/>
               <a:t>Fourth level</a:t>
             </a:r>
           </a:p>
           <a:p>
             <a:pPr lvl="4"/>
             <a:r>
-              <a:rPr lang="en-US" smtClean="0"/>
+              <a:rPr lang="en-US"/>
               <a:t>Fifth level</a:t>
             </a:r>
-            <a:endParaRPr lang="en-US"/>
           </a:p>
         </p:txBody>
       </p:sp>
@@ -2724,7 +2719,7 @@
           <a:p>
             <a:fld id="{5BCAD085-E8A6-8845-BD4E-CB4CCA059FC4}" type="datetimeFigureOut">
               <a:rPr lang="en-US" smtClean="0"/>
-              <a:t>1/27/13</a:t>
+              <a:t>4/25/2026</a:t>
             </a:fld>
             <a:endParaRPr lang="en-US"/>
           </a:p>
@@ -2802,7 +2797,7 @@
           <a:p>
             <a:fld id="{C1FF6DA9-008F-8B48-92A6-B652298478BF}" type="slidenum">
               <a:rPr lang="en-US" smtClean="0"/>
-              <a:t>‹#›</a:t>
+              <a:t>‹Nº›</a:t>
             </a:fld>
             <a:endParaRPr lang="en-US"/>
           </a:p>
@@ -3083,7 +3078,7 @@
 </file>
 
 <file path=ppt/slides/slide1.xml><?xml version="1.0" encoding="utf-8"?>
-<p:sld xmlns:a="http://schemas.openxmlformats.org/drawingml/2006/main" xmlns:p="http://schemas.openxmlformats.org/presentationml/2006/main" xmlns:r="http://schemas.openxmlformats.org/officeDocument/2006/relationships">
+<p:sld xmlns:a="http://schemas.openxmlformats.org/drawingml/2006/main" xmlns:r="http://schemas.openxmlformats.org/officeDocument/2006/relationships" xmlns:p="http://schemas.openxmlformats.org/presentationml/2006/main">
   <p:cSld>
     <p:spTree>
       <p:nvGrpSpPr>
@@ -3091,7 +3086,14 @@
         <p:cNvGrpSpPr/>
         <p:nvPr/>
       </p:nvGrpSpPr>
-      <p:grpSpPr/>
+      <p:grpSpPr>
+        <a:xfrm>
+          <a:off x="0" y="0"/>
+          <a:ext cx="0" cy="0"/>
+          <a:chOff x="0" y="0"/>
+          <a:chExt cx="0" cy="0"/>
+        </a:xfrm>
+      </p:grpSpPr>
       <p:sp>
         <p:nvSpPr>
           <p:cNvPr id="2" name="Rectangle 1"/>
@@ -3132,6 +3134,7 @@
           <a:lstStyle/>
           <a:p>
             <a:pPr algn="ctr"/>
+            <a:endParaRPr/>
           </a:p>
         </p:txBody>
       </p:sp>
@@ -3243,6 +3246,7 @@
           <a:lstStyle/>
           <a:p>
             <a:pPr algn="ctr"/>
+            <a:endParaRPr/>
           </a:p>
         </p:txBody>
       </p:sp>
@@ -3320,6 +3324,7 @@
           <a:lstStyle/>
           <a:p>
             <a:pPr algn="ctr"/>
+            <a:endParaRPr/>
           </a:p>
         </p:txBody>
       </p:sp>
@@ -3397,6 +3402,7 @@
           <a:lstStyle/>
           <a:p>
             <a:pPr algn="ctr"/>
+            <a:endParaRPr/>
           </a:p>
         </p:txBody>
       </p:sp>
@@ -3496,6 +3502,7 @@
           <a:lstStyle/>
           <a:p>
             <a:pPr algn="ctr"/>
+            <a:endParaRPr/>
           </a:p>
         </p:txBody>
       </p:sp>
@@ -3573,6 +3580,7 @@
           <a:lstStyle/>
           <a:p>
             <a:pPr algn="ctr"/>
+            <a:endParaRPr/>
           </a:p>
         </p:txBody>
       </p:sp>
@@ -3672,6 +3680,7 @@
           <a:lstStyle/>
           <a:p>
             <a:pPr algn="ctr"/>
+            <a:endParaRPr/>
           </a:p>
         </p:txBody>
       </p:sp>
@@ -3749,6 +3758,7 @@
           <a:lstStyle/>
           <a:p>
             <a:pPr algn="ctr"/>
+            <a:endParaRPr/>
           </a:p>
         </p:txBody>
       </p:sp>
@@ -3848,6 +3858,7 @@
           <a:lstStyle/>
           <a:p>
             <a:pPr algn="ctr"/>
+            <a:endParaRPr/>
           </a:p>
         </p:txBody>
       </p:sp>
@@ -3894,7 +3905,7 @@
 </file>
 
 <file path=ppt/slides/slide2.xml><?xml version="1.0" encoding="utf-8"?>
-<p:sld xmlns:a="http://schemas.openxmlformats.org/drawingml/2006/main" xmlns:p="http://schemas.openxmlformats.org/presentationml/2006/main" xmlns:r="http://schemas.openxmlformats.org/officeDocument/2006/relationships">
+<p:sld xmlns:a="http://schemas.openxmlformats.org/drawingml/2006/main" xmlns:r="http://schemas.openxmlformats.org/officeDocument/2006/relationships" xmlns:p="http://schemas.openxmlformats.org/presentationml/2006/main">
   <p:cSld>
     <p:spTree>
       <p:nvGrpSpPr>
@@ -3902,7 +3913,14 @@
         <p:cNvGrpSpPr/>
         <p:nvPr/>
       </p:nvGrpSpPr>
-      <p:grpSpPr/>
+      <p:grpSpPr>
+        <a:xfrm>
+          <a:off x="0" y="0"/>
+          <a:ext cx="0" cy="0"/>
+          <a:chOff x="0" y="0"/>
+          <a:chExt cx="0" cy="0"/>
+        </a:xfrm>
+      </p:grpSpPr>
       <p:sp>
         <p:nvSpPr>
           <p:cNvPr id="2" name="Rectangle 1"/>
@@ -3943,6 +3961,7 @@
           <a:lstStyle/>
           <a:p>
             <a:pPr algn="ctr"/>
+            <a:endParaRPr/>
           </a:p>
         </p:txBody>
       </p:sp>
@@ -4054,6 +4073,7 @@
           <a:lstStyle/>
           <a:p>
             <a:pPr algn="ctr"/>
+            <a:endParaRPr/>
           </a:p>
         </p:txBody>
       </p:sp>
@@ -4131,6 +4151,7 @@
           <a:lstStyle/>
           <a:p>
             <a:pPr algn="ctr"/>
+            <a:endParaRPr/>
           </a:p>
         </p:txBody>
       </p:sp>
@@ -4208,6 +4229,7 @@
           <a:lstStyle/>
           <a:p>
             <a:pPr algn="ctr"/>
+            <a:endParaRPr/>
           </a:p>
         </p:txBody>
       </p:sp>
@@ -4319,6 +4341,7 @@
           <a:lstStyle/>
           <a:p>
             <a:pPr algn="ctr"/>
+            <a:endParaRPr/>
           </a:p>
         </p:txBody>
       </p:sp>
@@ -4430,6 +4453,7 @@
           <a:lstStyle/>
           <a:p>
             <a:pPr algn="ctr"/>
+            <a:endParaRPr/>
           </a:p>
         </p:txBody>
       </p:sp>
@@ -4541,6 +4565,7 @@
           <a:lstStyle/>
           <a:p>
             <a:pPr algn="ctr"/>
+            <a:endParaRPr/>
           </a:p>
         </p:txBody>
       </p:sp>
@@ -4652,6 +4677,7 @@
           <a:lstStyle/>
           <a:p>
             <a:pPr algn="ctr"/>
+            <a:endParaRPr/>
           </a:p>
         </p:txBody>
       </p:sp>
@@ -4776,7 +4802,7 @@
 </file>
 
 <file path=ppt/slides/slide3.xml><?xml version="1.0" encoding="utf-8"?>
-<p:sld xmlns:a="http://schemas.openxmlformats.org/drawingml/2006/main" xmlns:p="http://schemas.openxmlformats.org/presentationml/2006/main" xmlns:r="http://schemas.openxmlformats.org/officeDocument/2006/relationships">
+<p:sld xmlns:a="http://schemas.openxmlformats.org/drawingml/2006/main" xmlns:r="http://schemas.openxmlformats.org/officeDocument/2006/relationships" xmlns:p="http://schemas.openxmlformats.org/presentationml/2006/main">
   <p:cSld>
     <p:spTree>
       <p:nvGrpSpPr>
@@ -4784,7 +4810,14 @@
         <p:cNvGrpSpPr/>
         <p:nvPr/>
       </p:nvGrpSpPr>
-      <p:grpSpPr/>
+      <p:grpSpPr>
+        <a:xfrm>
+          <a:off x="0" y="0"/>
+          <a:ext cx="0" cy="0"/>
+          <a:chOff x="0" y="0"/>
+          <a:chExt cx="0" cy="0"/>
+        </a:xfrm>
+      </p:grpSpPr>
       <p:sp>
         <p:nvSpPr>
           <p:cNvPr id="2" name="Rectangle 1"/>
@@ -4825,6 +4858,7 @@
           <a:lstStyle/>
           <a:p>
             <a:pPr algn="ctr"/>
+            <a:endParaRPr/>
           </a:p>
         </p:txBody>
       </p:sp>
@@ -4936,6 +4970,7 @@
           <a:lstStyle/>
           <a:p>
             <a:pPr algn="ctr"/>
+            <a:endParaRPr/>
           </a:p>
         </p:txBody>
       </p:sp>
@@ -5013,6 +5048,7 @@
           <a:lstStyle/>
           <a:p>
             <a:pPr algn="ctr"/>
+            <a:endParaRPr/>
           </a:p>
         </p:txBody>
       </p:sp>
@@ -5123,6 +5159,7 @@
           <a:lstStyle/>
           <a:p>
             <a:pPr algn="ctr"/>
+            <a:endParaRPr/>
           </a:p>
         </p:txBody>
       </p:sp>
@@ -5233,6 +5270,7 @@
           <a:lstStyle/>
           <a:p>
             <a:pPr algn="ctr"/>
+            <a:endParaRPr/>
           </a:p>
         </p:txBody>
       </p:sp>
@@ -5343,6 +5381,7 @@
           <a:lstStyle/>
           <a:p>
             <a:pPr algn="ctr"/>
+            <a:endParaRPr/>
           </a:p>
         </p:txBody>
       </p:sp>
@@ -5422,7 +5461,7 @@
 </file>
 
 <file path=ppt/slides/slide4.xml><?xml version="1.0" encoding="utf-8"?>
-<p:sld xmlns:a="http://schemas.openxmlformats.org/drawingml/2006/main" xmlns:p="http://schemas.openxmlformats.org/presentationml/2006/main" xmlns:r="http://schemas.openxmlformats.org/officeDocument/2006/relationships">
+<p:sld xmlns:a="http://schemas.openxmlformats.org/drawingml/2006/main" xmlns:r="http://schemas.openxmlformats.org/officeDocument/2006/relationships" xmlns:p="http://schemas.openxmlformats.org/presentationml/2006/main">
   <p:cSld>
     <p:spTree>
       <p:nvGrpSpPr>
@@ -5430,7 +5469,14 @@
         <p:cNvGrpSpPr/>
         <p:nvPr/>
       </p:nvGrpSpPr>
-      <p:grpSpPr/>
+      <p:grpSpPr>
+        <a:xfrm>
+          <a:off x="0" y="0"/>
+          <a:ext cx="0" cy="0"/>
+          <a:chOff x="0" y="0"/>
+          <a:chExt cx="0" cy="0"/>
+        </a:xfrm>
+      </p:grpSpPr>
       <p:sp>
         <p:nvSpPr>
           <p:cNvPr id="2" name="Rectangle 1"/>
@@ -5471,6 +5517,7 @@
           <a:lstStyle/>
           <a:p>
             <a:pPr algn="ctr"/>
+            <a:endParaRPr/>
           </a:p>
         </p:txBody>
       </p:sp>
@@ -5582,6 +5629,7 @@
           <a:lstStyle/>
           <a:p>
             <a:pPr algn="ctr"/>
+            <a:endParaRPr/>
           </a:p>
         </p:txBody>
       </p:sp>
@@ -5659,6 +5707,7 @@
           <a:lstStyle/>
           <a:p>
             <a:pPr algn="ctr"/>
+            <a:endParaRPr/>
           </a:p>
         </p:txBody>
       </p:sp>
@@ -5736,6 +5785,7 @@
           <a:lstStyle/>
           <a:p>
             <a:pPr algn="ctr"/>
+            <a:endParaRPr/>
           </a:p>
         </p:txBody>
       </p:sp>
@@ -5846,6 +5896,7 @@
           <a:lstStyle/>
           <a:p>
             <a:pPr algn="ctr"/>
+            <a:endParaRPr/>
           </a:p>
         </p:txBody>
       </p:sp>
@@ -5923,6 +5974,7 @@
           <a:lstStyle/>
           <a:p>
             <a:pPr algn="ctr"/>
+            <a:endParaRPr/>
           </a:p>
         </p:txBody>
       </p:sp>
@@ -6033,6 +6085,7 @@
           <a:lstStyle/>
           <a:p>
             <a:pPr algn="ctr"/>
+            <a:endParaRPr/>
           </a:p>
         </p:txBody>
       </p:sp>
@@ -6110,6 +6163,7 @@
           <a:lstStyle/>
           <a:p>
             <a:pPr algn="ctr"/>
+            <a:endParaRPr/>
           </a:p>
         </p:txBody>
       </p:sp>
@@ -6189,7 +6243,7 @@
 </file>
 
 <file path=ppt/slides/slide5.xml><?xml version="1.0" encoding="utf-8"?>
-<p:sld xmlns:a="http://schemas.openxmlformats.org/drawingml/2006/main" xmlns:p="http://schemas.openxmlformats.org/presentationml/2006/main" xmlns:r="http://schemas.openxmlformats.org/officeDocument/2006/relationships">
+<p:sld xmlns:a="http://schemas.openxmlformats.org/drawingml/2006/main" xmlns:r="http://schemas.openxmlformats.org/officeDocument/2006/relationships" xmlns:p="http://schemas.openxmlformats.org/presentationml/2006/main">
   <p:cSld>
     <p:spTree>
       <p:nvGrpSpPr>
@@ -6197,7 +6251,14 @@
         <p:cNvGrpSpPr/>
         <p:nvPr/>
       </p:nvGrpSpPr>
-      <p:grpSpPr/>
+      <p:grpSpPr>
+        <a:xfrm>
+          <a:off x="0" y="0"/>
+          <a:ext cx="0" cy="0"/>
+          <a:chOff x="0" y="0"/>
+          <a:chExt cx="0" cy="0"/>
+        </a:xfrm>
+      </p:grpSpPr>
       <p:sp>
         <p:nvSpPr>
           <p:cNvPr id="2" name="Rectangle 1"/>
@@ -6238,6 +6299,7 @@
           <a:lstStyle/>
           <a:p>
             <a:pPr algn="ctr"/>
+            <a:endParaRPr/>
           </a:p>
         </p:txBody>
       </p:sp>
@@ -6349,6 +6411,7 @@
           <a:lstStyle/>
           <a:p>
             <a:pPr algn="ctr"/>
+            <a:endParaRPr/>
           </a:p>
         </p:txBody>
       </p:sp>
@@ -6426,6 +6489,7 @@
           <a:lstStyle/>
           <a:p>
             <a:pPr algn="ctr"/>
+            <a:endParaRPr/>
           </a:p>
         </p:txBody>
       </p:sp>
@@ -6570,6 +6634,7 @@
           <a:lstStyle/>
           <a:p>
             <a:pPr algn="ctr"/>
+            <a:endParaRPr/>
           </a:p>
         </p:txBody>
       </p:sp>
@@ -6714,6 +6779,7 @@
           <a:lstStyle/>
           <a:p>
             <a:pPr algn="ctr"/>
+            <a:endParaRPr/>
           </a:p>
         </p:txBody>
       </p:sp>
@@ -6858,6 +6924,7 @@
           <a:lstStyle/>
           <a:p>
             <a:pPr algn="ctr"/>
+            <a:endParaRPr/>
           </a:p>
         </p:txBody>
       </p:sp>
@@ -7002,6 +7069,7 @@
           <a:lstStyle/>
           <a:p>
             <a:pPr algn="ctr"/>
+            <a:endParaRPr/>
           </a:p>
         </p:txBody>
       </p:sp>

</xml_diff>